<commit_message>
added problem set 1
</commit_message>
<xml_diff>
--- a/lectures/lecture2/lecture2.pptx
+++ b/lectures/lecture2/lecture2.pptx
@@ -130,7 +130,7 @@
   <pc:docChgLst>
     <pc:chgData name="Toby Donaldson" userId="2e6e5431-bb17-4c41-9985-d39c50d83c73" providerId="ADAL" clId="{F31BC264-820E-54C4-A6D1-F92AF9CC222E}"/>
     <pc:docChg chg="undo custSel addSld delSld modSld">
-      <pc:chgData name="Toby Donaldson" userId="2e6e5431-bb17-4c41-9985-d39c50d83c73" providerId="ADAL" clId="{F31BC264-820E-54C4-A6D1-F92AF9CC222E}" dt="2026-05-12T05:01:19.816" v="1201" actId="5793"/>
+      <pc:chgData name="Toby Donaldson" userId="2e6e5431-bb17-4c41-9985-d39c50d83c73" providerId="ADAL" clId="{F31BC264-820E-54C4-A6D1-F92AF9CC222E}" dt="2026-05-12T04:25:55.058" v="1143" actId="20577"/>
       <pc:docMkLst>
         <pc:docMk/>
       </pc:docMkLst>
@@ -363,13 +363,13 @@
         </pc:cxnChg>
       </pc:sldChg>
       <pc:sldChg chg="modSp new mod">
-        <pc:chgData name="Toby Donaldson" userId="2e6e5431-bb17-4c41-9985-d39c50d83c73" providerId="ADAL" clId="{F31BC264-820E-54C4-A6D1-F92AF9CC222E}" dt="2026-05-12T05:01:19.816" v="1201" actId="5793"/>
+        <pc:chgData name="Toby Donaldson" userId="2e6e5431-bb17-4c41-9985-d39c50d83c73" providerId="ADAL" clId="{F31BC264-820E-54C4-A6D1-F92AF9CC222E}" dt="2026-05-12T04:25:55.058" v="1143" actId="20577"/>
         <pc:sldMkLst>
           <pc:docMk/>
           <pc:sldMk cId="1400040307" sldId="267"/>
         </pc:sldMkLst>
         <pc:spChg chg="mod">
-          <ac:chgData name="Toby Donaldson" userId="2e6e5431-bb17-4c41-9985-d39c50d83c73" providerId="ADAL" clId="{F31BC264-820E-54C4-A6D1-F92AF9CC222E}" dt="2026-05-12T05:01:05.995" v="1144" actId="20577"/>
+          <ac:chgData name="Toby Donaldson" userId="2e6e5431-bb17-4c41-9985-d39c50d83c73" providerId="ADAL" clId="{F31BC264-820E-54C4-A6D1-F92AF9CC222E}" dt="2026-05-12T04:25:33.040" v="1090" actId="20577"/>
           <ac:spMkLst>
             <pc:docMk/>
             <pc:sldMk cId="1400040307" sldId="267"/>
@@ -377,7 +377,7 @@
           </ac:spMkLst>
         </pc:spChg>
         <pc:spChg chg="mod">
-          <ac:chgData name="Toby Donaldson" userId="2e6e5431-bb17-4c41-9985-d39c50d83c73" providerId="ADAL" clId="{F31BC264-820E-54C4-A6D1-F92AF9CC222E}" dt="2026-05-12T05:01:19.816" v="1201" actId="5793"/>
+          <ac:chgData name="Toby Donaldson" userId="2e6e5431-bb17-4c41-9985-d39c50d83c73" providerId="ADAL" clId="{F31BC264-820E-54C4-A6D1-F92AF9CC222E}" dt="2026-05-12T04:25:55.058" v="1143" actId="20577"/>
           <ac:spMkLst>
             <pc:docMk/>
             <pc:sldMk cId="1400040307" sldId="267"/>
@@ -4443,7 +4443,7 @@
           <a:p>
             <a:r>
               <a:rPr lang="en-US" dirty="0"/>
-              <a:t>Practice Problems</a:t>
+              <a:t>Practice Problem</a:t>
             </a:r>
           </a:p>
         </p:txBody>
@@ -4473,14 +4473,21 @@
               <a:buNone/>
             </a:pPr>
             <a:r>
+              <a:rPr lang="en-US"/>
+              <a:t>In C++, </a:t>
+            </a:r>
+            <a:r>
               <a:rPr lang="en-US" dirty="0"/>
-              <a:t>Do problems 1, 2, and 3 </a:t>
-            </a:r>
-            <a:r>
-              <a:rPr lang="en-US"/>
-              <a:t>in the notes …</a:t>
-            </a:r>
-            <a:endParaRPr lang="en-US" dirty="0"/>
+              <a:t>c</a:t>
+            </a:r>
+            <a:r>
+              <a:rPr lang="en-US"/>
+              <a:t>reate </a:t>
+            </a:r>
+            <a:r>
+              <a:rPr lang="en-US" dirty="0"/>
+              <a:t>the list in the previous slide …</a:t>
+            </a:r>
           </a:p>
         </p:txBody>
       </p:sp>

</xml_diff>